<commit_message>
Adopt capped error-filter strategy with positive development PnL and verified exports
</commit_message>
<xml_diff>
--- a/docs/presentation.pptx
+++ b/docs/presentation.pptx
@@ -4061,7 +4061,7 @@
               <a:spcAft>
                 <a:spcPts val="1200"/>
               </a:spcAft>
-              <a:defRPr sz="2400" b="0">
+              <a:defRPr sz="2300" b="0">
                 <a:solidFill>
                   <a:srgbClr val="445368"/>
                 </a:solidFill>
@@ -4077,7 +4077,7 @@
               <a:spcAft>
                 <a:spcPts val="1200"/>
               </a:spcAft>
-              <a:defRPr sz="2400" b="0">
+              <a:defRPr sz="2300" b="0">
                 <a:solidFill>
                   <a:srgbClr val="445368"/>
                 </a:solidFill>
@@ -4085,7 +4085,7 @@
               </a:defRPr>
             </a:pPr>
             <a:r>
-              <a:t>Позиции 0: нет сделок, P&amp;L = 0, просадка = 0.</a:t>
+              <a:t>Стратегия: +0.115; после условных затрат +0.080.</a:t>
             </a:r>
           </a:p>
           <a:p>
@@ -4093,7 +4093,7 @@
               <a:spcAft>
                 <a:spcPts val="1200"/>
               </a:spcAft>
-              <a:defRPr sz="2400" b="0">
+              <a:defRPr sz="2300" b="0">
                 <a:solidFill>
                   <a:srgbClr val="445368"/>
                 </a:solidFill>
@@ -4101,7 +4101,7 @@
               </a:defRPr>
             </a:pPr>
             <a:r>
-              <a:t>Активный +0,122 отклонён: 72% выигрыша в одном блоке.</a:t>
+              <a:t>Максимум одна активная неделя на 13 недель.</a:t>
             </a:r>
           </a:p>
           <a:p>
@@ -4109,7 +4109,7 @@
               <a:spcAft>
                 <a:spcPts val="1200"/>
               </a:spcAft>
-              <a:defRPr sz="2400" b="0">
+              <a:defRPr sz="2300" b="0">
                 <a:solidFill>
                   <a:srgbClr val="445368"/>
                 </a:solidFill>
@@ -4117,7 +4117,23 @@
               </a:defRPr>
             </a:pPr>
             <a:r>
-              <a:t>CSV, модель, код, отчёт, проверки и демо готовы.</a:t>
+              <a:t>5 прибыльных блоков; лучший — 37% положительного результата.</a:t>
+            </a:r>
+          </a:p>
+          <a:p>
+            <a:pPr>
+              <a:spcAft>
+                <a:spcPts val="1200"/>
+              </a:spcAft>
+              <a:defRPr sz="2300" b="0">
+                <a:solidFill>
+                  <a:srgbClr val="445368"/>
+                </a:solidFill>
+                <a:latin typeface="DejaVu Sans"/>
+              </a:defRPr>
+            </a:pPr>
+            <a:r>
+              <a:t>Это историческая оценка; будущая прибыль не гарантируется.</a:t>
             </a:r>
           </a:p>
         </p:txBody>

</xml_diff>

<commit_message>
Audit sensitivity and outlier risk, freeze CSV hashes and finalize submission notes
</commit_message>
<xml_diff>
--- a/docs/presentation.pptx
+++ b/docs/presentation.pptx
@@ -4117,7 +4117,7 @@
               </a:defRPr>
             </a:pPr>
             <a:r>
-              <a:t>5 прибыльных блоков; лучший — 37% положительного результата.</a:t>
+              <a:t>5 прибыльных блоков, 2 убыточных; выборка небольшая.</a:t>
             </a:r>
           </a:p>
           <a:p>
@@ -4133,7 +4133,7 @@
               </a:defRPr>
             </a:pPr>
             <a:r>
-              <a:t>Это историческая оценка; будущая прибыль не гарантируется.</a:t>
+              <a:t>Порог ±10%: плюс; без 2 лучших с затратами: минус.</a:t>
             </a:r>
           </a:p>
         </p:txBody>
@@ -4172,7 +4172,7 @@
               </a:defRPr>
             </a:pPr>
             <a:r>
-              <a:t>Следующий шаг после конкурса: новые котировки, устойчивый выбор режима и проверка экономической пользы.</a:t>
+              <a:t>Будущая прибыль не гарантируется. Следующий шаг — проверка на новых котировках.</a:t>
             </a:r>
           </a:p>
         </p:txBody>

</xml_diff>